<commit_message>
Update supervisor deck with clean-machine reproductions
</commit_message>
<xml_diff>
--- a/presentation/2026-07-14-supervisor-update/supervisor_update.pptx
+++ b/presentation/2026-07-14-supervisor-update/supervisor_update.pptx
@@ -6253,7 +6253,7 @@
               </a:defRPr>
             </a:pPr>
             <a:r>
-              <a:t>Kaggle token and CLI work; the account currently has no competition submission.</a:t>
+              <a:t>Clean rebuild: 23,869 chains / 10.87M residues / zero parser errors in 4.6 minutes.</a:t>
             </a:r>
           </a:p>
           <a:p>
@@ -6272,7 +6272,7 @@
               </a:defRPr>
             </a:pPr>
             <a:r>
-              <a:t>Raw data validated: 61 GiB with all CSV, MSA and 8,670 PDB CIF components present.</a:t>
+              <a:t>Clean rerun: dummy 0.0687, top-1 0.2983 and current pipeline 0.3072.</a:t>
             </a:r>
           </a:p>
           <a:p>
@@ -6291,7 +6291,7 @@
               </a:defRPr>
             </a:pPr>
             <a:r>
-              <a:t>WSL cap configured to 18 GB RAM + 8 GB swap; restart is required to apply it.</a:t>
+              <a:t>Kaggle token and CLI work; the account currently has no competition submission.</a:t>
             </a:r>
           </a:p>
           <a:p>
@@ -6310,7 +6310,7 @@
               </a:defRPr>
             </a:pPr>
             <a:r>
-              <a:t>CIF rebuild defaults to six workers to preserve Windows headroom.</a:t>
+              <a:t>WSL cap configured to 18 GB RAM + 8 GB swap; restart is required to apply it.</a:t>
             </a:r>
           </a:p>
         </p:txBody>
@@ -9676,7 +9676,7 @@
               </a:defRPr>
             </a:pPr>
             <a:r>
-              <a:t>A faithful top-1 reproduction scored 0.2973 temporal-safe using exhaustive composite similarity.</a:t>
+              <a:t>A faithful top-1 reproduction scored 0.2983 temporal-safe using exhaustive composite similarity.</a:t>
             </a:r>
           </a:p>
           <a:p>

</xml_diff>

<commit_message>
Record verified Kaggle late submission
</commit_message>
<xml_diff>
--- a/presentation/2026-07-14-supervisor-update/supervisor_update.pptx
+++ b/presentation/2026-07-14-supervisor-update/supervisor_update.pptx
@@ -6207,7 +6207,7 @@
               <a:spcAft>
                 <a:spcPts val="1100"/>
               </a:spcAft>
-              <a:defRPr sz="2000">
+              <a:defRPr sz="1900">
                 <a:solidFill>
                   <a:srgbClr val="172033"/>
                 </a:solidFill>
@@ -6226,7 +6226,7 @@
               <a:spcAft>
                 <a:spcPts val="1100"/>
               </a:spcAft>
-              <a:defRPr sz="2000">
+              <a:defRPr sz="1900">
                 <a:solidFill>
                   <a:srgbClr val="172033"/>
                 </a:solidFill>
@@ -6245,7 +6245,7 @@
               <a:spcAft>
                 <a:spcPts val="1100"/>
               </a:spcAft>
-              <a:defRPr sz="2000">
+              <a:defRPr sz="1900">
                 <a:solidFill>
                   <a:srgbClr val="172033"/>
                 </a:solidFill>
@@ -6264,7 +6264,7 @@
               <a:spcAft>
                 <a:spcPts val="1100"/>
               </a:spcAft>
-              <a:defRPr sz="2000">
+              <a:defRPr sz="1900">
                 <a:solidFill>
                   <a:srgbClr val="172033"/>
                 </a:solidFill>
@@ -6283,7 +6283,7 @@
               <a:spcAft>
                 <a:spcPts val="1100"/>
               </a:spcAft>
-              <a:defRPr sz="2000">
+              <a:defRPr sz="1900">
                 <a:solidFill>
                   <a:srgbClr val="172033"/>
                 </a:solidFill>
@@ -6291,7 +6291,7 @@
               </a:defRPr>
             </a:pPr>
             <a:r>
-              <a:t>Kaggle token and CLI work; the account currently has no competition submission.</a:t>
+              <a:t>Offline Kaggle kernel v4 completed; its exact 2,515-row output passed validation.</a:t>
             </a:r>
           </a:p>
           <a:p>
@@ -6302,7 +6302,26 @@
               <a:spcAft>
                 <a:spcPts val="1100"/>
               </a:spcAft>
-              <a:defRPr sz="2000">
+              <a:defRPr sz="1900">
+                <a:solidFill>
+                  <a:srgbClr val="172033"/>
+                </a:solidFill>
+                <a:latin typeface="Aptos"/>
+              </a:defRPr>
+            </a:pPr>
+            <a:r>
+              <a:t>Late submission 54662648 is accepted and awaiting the hidden-set score.</a:t>
+            </a:r>
+          </a:p>
+          <a:p>
+            <a:pPr>
+              <a:lnSpc>
+                <a:spcPct val="106000"/>
+              </a:lnSpc>
+              <a:spcAft>
+                <a:spcPts val="1100"/>
+              </a:spcAft>
+              <a:defRPr sz="1900">
                 <a:solidFill>
                   <a:srgbClr val="172033"/>
                 </a:solidFill>
@@ -6750,7 +6769,7 @@
               </a:defRPr>
             </a:pPr>
             <a:r>
-              <a:t>1. Finish the data audit and rebuild reusable template artifacts on the main machine.</a:t>
+              <a:t>1. Record the Kaggle baseline hidden-set score when submission 54662648 finishes.</a:t>
             </a:r>
           </a:p>
           <a:p>
@@ -6769,7 +6788,7 @@
               </a:defRPr>
             </a:pPr>
             <a:r>
-              <a:t>2. Reproduce B0 from scratch and freeze its artifact bundle.</a:t>
+              <a:t>2. Add pretrained candidates and first measure oracle-pool TM.</a:t>
             </a:r>
           </a:p>
           <a:p>
@@ -6788,7 +6807,7 @@
               </a:defRPr>
             </a:pPr>
             <a:r>
-              <a:t>3. Run and validate a Kaggle baseline notebook; late-submit its exact successful version.</a:t>
+              <a:t>3. Proceed to fusion only if candidate sources are complementary.</a:t>
             </a:r>
           </a:p>
           <a:p>
@@ -6807,7 +6826,7 @@
               </a:defRPr>
             </a:pPr>
             <a:r>
-              <a:t>4. Add pretrained candidates and first measure oracle-pool TM.</a:t>
+              <a:t>4. Require geometry v2 to eliminate the kink regression.</a:t>
             </a:r>
           </a:p>
           <a:p>
@@ -6826,26 +6845,7 @@
               </a:defRPr>
             </a:pPr>
             <a:r>
-              <a:t>5. Proceed to fusion only if candidate sources are complementary.</a:t>
-            </a:r>
-          </a:p>
-          <a:p>
-            <a:pPr>
-              <a:lnSpc>
-                <a:spcPct val="106000"/>
-              </a:lnSpc>
-              <a:spcAft>
-                <a:spcPts val="1100"/>
-              </a:spcAft>
-              <a:defRPr sz="2000">
-                <a:solidFill>
-                  <a:srgbClr val="172033"/>
-                </a:solidFill>
-                <a:latin typeface="Aptos"/>
-              </a:defRPr>
-            </a:pPr>
-            <a:r>
-              <a:t>6. Require geometry v2 to eliminate the kink regression.</a:t>
+              <a:t>5. Run paired family/time-aware ablations and freeze the final holdout.</a:t>
             </a:r>
           </a:p>
         </p:txBody>

</xml_diff>

<commit_message>
Analyze Kaggle private score and hybrid reference
</commit_message>
<xml_diff>
--- a/presentation/2026-07-14-supervisor-update/supervisor_update.pptx
+++ b/presentation/2026-07-14-supervisor-update/supervisor_update.pptx
@@ -6310,7 +6310,7 @@
               </a:defRPr>
             </a:pPr>
             <a:r>
-              <a:t>Late submission 54662648 is accepted and awaiting the hidden-set score.</a:t>
+              <a:t>Late submission 54662648 completed: 0.60084 public / 0.60175 private.</a:t>
             </a:r>
           </a:p>
           <a:p>
@@ -6769,7 +6769,7 @@
               </a:defRPr>
             </a:pPr>
             <a:r>
-              <a:t>1. Record the Kaggle baseline hidden-set score when submission 54662648 finishes.</a:t>
+              <a:t>1. Harden fail-closed cutoff parsing and explicit self-PDB exclusion.</a:t>
             </a:r>
           </a:p>
           <a:p>
@@ -7277,7 +7277,7 @@
               <a:spcAft>
                 <a:spcPts val="1100"/>
               </a:spcAft>
-              <a:defRPr sz="2100">
+              <a:defRPr sz="1900">
                 <a:solidFill>
                   <a:srgbClr val="172033"/>
                 </a:solidFill>
@@ -7296,7 +7296,7 @@
               <a:spcAft>
                 <a:spcPts val="1100"/>
               </a:spcAft>
-              <a:defRPr sz="2100">
+              <a:defRPr sz="1900">
                 <a:solidFill>
                   <a:srgbClr val="172033"/>
                 </a:solidFill>
@@ -7315,7 +7315,7 @@
               <a:spcAft>
                 <a:spcPts val="1100"/>
               </a:spcAft>
-              <a:defRPr sz="2100">
+              <a:defRPr sz="1900">
                 <a:solidFill>
                   <a:srgbClr val="172033"/>
                 </a:solidFill>
@@ -7323,7 +7323,7 @@
               </a:defRPr>
             </a:pPr>
             <a:r>
-              <a:t>Main empirical win: +0.0955 TM from better template recall.</a:t>
+              <a:t>Kaggle: 0.60084 public / 0.60175 private, versus reported TBM-only 0.59298.</a:t>
             </a:r>
           </a:p>
           <a:p>
@@ -7334,7 +7334,7 @@
               <a:spcAft>
                 <a:spcPts val="1100"/>
               </a:spcAft>
-              <a:defRPr sz="2100">
+              <a:defRPr sz="1900">
                 <a:solidFill>
                   <a:srgbClr val="172033"/>
                 </a:solidFill>
@@ -7342,7 +7342,7 @@
               </a:defRPr>
             </a:pPr>
             <a:r>
-              <a:t>Geometry v1 improves clashes/backbone spacing, but is TM-neutral and increases sharp kinks.</a:t>
+              <a:t>Main empirical win: +0.0955 TM from better template recall.</a:t>
             </a:r>
           </a:p>
           <a:p>
@@ -7353,7 +7353,26 @@
               <a:spcAft>
                 <a:spcPts val="1100"/>
               </a:spcAft>
-              <a:defRPr sz="2100">
+              <a:defRPr sz="1900">
+                <a:solidFill>
+                  <a:srgbClr val="172033"/>
+                </a:solidFill>
+                <a:latin typeface="Aptos"/>
+              </a:defRPr>
+            </a:pPr>
+            <a:r>
+              <a:t>Geometry v1 improves clashes/backbone spacing, but is TM-neutral and increases sharp kinks.</a:t>
+            </a:r>
+          </a:p>
+          <a:p>
+            <a:pPr>
+              <a:lnSpc>
+                <a:spcPct val="106000"/>
+              </a:lnSpc>
+              <a:spcAft>
+                <a:spcPts val="1100"/>
+              </a:spcAft>
+              <a:defRPr sz="1900">
                 <a:solidFill>
                   <a:srgbClr val="172033"/>
                 </a:solidFill>
@@ -7535,7 +7554,7 @@
               <a:spcAft>
                 <a:spcPts val="1100"/>
               </a:spcAft>
-              <a:defRPr sz="2000">
+              <a:defRPr sz="1800">
                 <a:solidFill>
                   <a:srgbClr val="172033"/>
                 </a:solidFill>
@@ -7554,7 +7573,7 @@
               <a:spcAft>
                 <a:spcPts val="1100"/>
               </a:spcAft>
-              <a:defRPr sz="2000">
+              <a:defRPr sz="1800">
                 <a:solidFill>
                   <a:srgbClr val="172033"/>
                 </a:solidFill>
@@ -7562,7 +7581,7 @@
               </a:defRPr>
             </a:pPr>
             <a:r>
-              <a:t>Composite ablation: reports/thesis_notes/composite_ablation.md</a:t>
+              <a:t>Kaggle 0.60175 audit: reports/thesis_notes/kaggle_submission_analysis.md</a:t>
             </a:r>
           </a:p>
           <a:p>
@@ -7573,7 +7592,7 @@
               <a:spcAft>
                 <a:spcPts val="1100"/>
               </a:spcAft>
-              <a:defRPr sz="2000">
+              <a:defRPr sz="1800">
                 <a:solidFill>
                   <a:srgbClr val="172033"/>
                 </a:solidFill>
@@ -7581,7 +7600,7 @@
               </a:defRPr>
             </a:pPr>
             <a:r>
-              <a:t>Refinement truthfulness: reports/thesis_notes/refine_ablation.md</a:t>
+              <a:t>Composite ablation: reports/thesis_notes/composite_ablation.md</a:t>
             </a:r>
           </a:p>
           <a:p>
@@ -7592,7 +7611,7 @@
               <a:spcAft>
                 <a:spcPts val="1100"/>
               </a:spcAft>
-              <a:defRPr sz="2000">
+              <a:defRPr sz="1800">
                 <a:solidFill>
                   <a:srgbClr val="172033"/>
                 </a:solidFill>
@@ -7600,7 +7619,7 @@
               </a:defRPr>
             </a:pPr>
             <a:r>
-              <a:t>Top-1 reproduction and leakage: reproduce_top1.md + leakage_demo.md</a:t>
+              <a:t>Refinement truthfulness: reports/thesis_notes/refine_ablation.md</a:t>
             </a:r>
           </a:p>
           <a:p>
@@ -7611,7 +7630,7 @@
               <a:spcAft>
                 <a:spcPts val="1100"/>
               </a:spcAft>
-              <a:defRPr sz="2000">
+              <a:defRPr sz="1800">
                 <a:solidFill>
                   <a:srgbClr val="172033"/>
                 </a:solidFill>
@@ -7619,7 +7638,7 @@
               </a:defRPr>
             </a:pPr>
             <a:r>
-              <a:t>Full chronology: LOG.md; extension: PLAN.md + research_plan_review.md</a:t>
+              <a:t>Top-1 reproduction and leakage: reproduce_top1.md + leakage_demo.md</a:t>
             </a:r>
           </a:p>
           <a:p>
@@ -7630,7 +7649,26 @@
               <a:spcAft>
                 <a:spcPts val="1100"/>
               </a:spcAft>
-              <a:defRPr sz="2000">
+              <a:defRPr sz="1800">
+                <a:solidFill>
+                  <a:srgbClr val="172033"/>
+                </a:solidFill>
+                <a:latin typeface="Aptos"/>
+              </a:defRPr>
+            </a:pPr>
+            <a:r>
+              <a:t>Full chronology: LOG.md; extension: PLAN.md + research_plan_review.md</a:t>
+            </a:r>
+          </a:p>
+          <a:p>
+            <a:pPr>
+              <a:lnSpc>
+                <a:spcPct val="106000"/>
+              </a:lnSpc>
+              <a:spcAft>
+                <a:spcPts val="1100"/>
+              </a:spcAft>
+              <a:defRPr sz="1800">
                 <a:solidFill>
                   <a:srgbClr val="172033"/>
                 </a:solidFill>

</xml_diff>